<commit_message>
examples and next-lecture references
</commit_message>
<xml_diff>
--- a/slides/3_LLMs.pptx
+++ b/slides/3_LLMs.pptx
@@ -5,7 +5,7 @@
     <p:sldMasterId id="2147483648" r:id="rId1"/>
   </p:sldMasterIdLst>
   <p:notesMasterIdLst>
-    <p:notesMasterId r:id="rId18"/>
+    <p:notesMasterId r:id="rId19"/>
   </p:notesMasterIdLst>
   <p:sldIdLst>
     <p:sldId id="256" r:id="rId2"/>
@@ -24,6 +24,7 @@
     <p:sldId id="285" r:id="rId15"/>
     <p:sldId id="809" r:id="rId16"/>
     <p:sldId id="804" r:id="rId17"/>
+    <p:sldId id="815" r:id="rId18"/>
   </p:sldIdLst>
   <p:sldSz cx="12192000" cy="6858000"/>
   <p:notesSz cx="6858000" cy="9144000"/>
@@ -7036,7 +7037,7 @@
           <a:p>
             <a:fld id="{B854A0A5-3125-4A93-A463-B2CA0DCE058B}" type="datetimeFigureOut">
               <a:rPr lang="en-GB" smtClean="0"/>
-              <a:t>15/09/2025</a:t>
+              <a:t>17/09/2025</a:t>
             </a:fld>
             <a:endParaRPr lang="en-GB"/>
           </a:p>
@@ -7453,7 +7454,7 @@
           <a:p>
             <a:fld id="{7128456D-5ACD-4673-BCE9-52505EC32CEF}" type="datetime1">
               <a:rPr lang="en-GB" smtClean="0"/>
-              <a:t>15/09/2025</a:t>
+              <a:t>17/09/2025</a:t>
             </a:fld>
             <a:endParaRPr lang="en-GB"/>
           </a:p>
@@ -7653,7 +7654,7 @@
           <a:p>
             <a:fld id="{D99A2639-5270-4811-807B-89D4AE95E7ED}" type="datetime1">
               <a:rPr lang="en-GB" smtClean="0"/>
-              <a:t>15/09/2025</a:t>
+              <a:t>17/09/2025</a:t>
             </a:fld>
             <a:endParaRPr lang="en-GB"/>
           </a:p>
@@ -7863,7 +7864,7 @@
           <a:p>
             <a:fld id="{B552976C-D408-4E27-8D02-D7795F6D8A01}" type="datetime1">
               <a:rPr lang="en-GB" smtClean="0"/>
-              <a:t>15/09/2025</a:t>
+              <a:t>17/09/2025</a:t>
             </a:fld>
             <a:endParaRPr lang="en-GB"/>
           </a:p>
@@ -8063,7 +8064,7 @@
           <a:p>
             <a:fld id="{0B763083-041D-491F-A9FE-D51D99E0B41E}" type="datetime1">
               <a:rPr lang="en-GB" smtClean="0"/>
-              <a:t>15/09/2025</a:t>
+              <a:t>17/09/2025</a:t>
             </a:fld>
             <a:endParaRPr lang="en-GB"/>
           </a:p>
@@ -8339,7 +8340,7 @@
           <a:p>
             <a:fld id="{409455E6-A1CA-4CB6-9964-88D5086DA5CA}" type="datetime1">
               <a:rPr lang="en-GB" smtClean="0"/>
-              <a:t>15/09/2025</a:t>
+              <a:t>17/09/2025</a:t>
             </a:fld>
             <a:endParaRPr lang="en-GB"/>
           </a:p>
@@ -8607,7 +8608,7 @@
           <a:p>
             <a:fld id="{FAD82E38-24C1-4A8F-B916-1E714FC129DD}" type="datetime1">
               <a:rPr lang="en-GB" smtClean="0"/>
-              <a:t>15/09/2025</a:t>
+              <a:t>17/09/2025</a:t>
             </a:fld>
             <a:endParaRPr lang="en-GB"/>
           </a:p>
@@ -9022,7 +9023,7 @@
           <a:p>
             <a:fld id="{BC17BCDC-BAA6-44B5-B642-6F28D623ABB1}" type="datetime1">
               <a:rPr lang="en-GB" smtClean="0"/>
-              <a:t>15/09/2025</a:t>
+              <a:t>17/09/2025</a:t>
             </a:fld>
             <a:endParaRPr lang="en-GB"/>
           </a:p>
@@ -9164,7 +9165,7 @@
           <a:p>
             <a:fld id="{01D4BEC3-2CF9-4B19-A0A5-E70A0675B677}" type="datetime1">
               <a:rPr lang="en-GB" smtClean="0"/>
-              <a:t>15/09/2025</a:t>
+              <a:t>17/09/2025</a:t>
             </a:fld>
             <a:endParaRPr lang="en-GB"/>
           </a:p>
@@ -9277,7 +9278,7 @@
           <a:p>
             <a:fld id="{98E28BFD-B06D-4A45-8453-724AC7BA29C5}" type="datetime1">
               <a:rPr lang="en-GB" smtClean="0"/>
-              <a:t>15/09/2025</a:t>
+              <a:t>17/09/2025</a:t>
             </a:fld>
             <a:endParaRPr lang="en-GB"/>
           </a:p>
@@ -9590,7 +9591,7 @@
           <a:p>
             <a:fld id="{A14D99B0-2926-4194-B668-6A0D6123824C}" type="datetime1">
               <a:rPr lang="en-GB" smtClean="0"/>
-              <a:t>15/09/2025</a:t>
+              <a:t>17/09/2025</a:t>
             </a:fld>
             <a:endParaRPr lang="en-GB"/>
           </a:p>
@@ -9879,7 +9880,7 @@
           <a:p>
             <a:fld id="{29F03426-21FD-40F4-9F0B-AD19F2317DCA}" type="datetime1">
               <a:rPr lang="en-GB" smtClean="0"/>
-              <a:t>15/09/2025</a:t>
+              <a:t>17/09/2025</a:t>
             </a:fld>
             <a:endParaRPr lang="en-GB"/>
           </a:p>
@@ -10122,7 +10123,7 @@
           <a:p>
             <a:fld id="{0369896D-5D36-4D31-A0CE-0C2BFB17B225}" type="datetime1">
               <a:rPr lang="en-GB" smtClean="0"/>
-              <a:t>15/09/2025</a:t>
+              <a:t>17/09/2025</a:t>
             </a:fld>
             <a:endParaRPr lang="en-GB"/>
           </a:p>
@@ -15401,6 +15402,365 @@
     <p:extLst>
       <p:ext uri="{BB962C8B-B14F-4D97-AF65-F5344CB8AC3E}">
         <p14:creationId xmlns:p14="http://schemas.microsoft.com/office/powerpoint/2010/main" val="2061575047"/>
+      </p:ext>
+    </p:extLst>
+  </p:cSld>
+  <p:clrMapOvr>
+    <a:masterClrMapping/>
+  </p:clrMapOvr>
+</p:sld>
+</file>
+
+<file path=ppt/slides/slide17.xml><?xml version="1.0" encoding="utf-8"?>
+<p:sld xmlns:a="http://schemas.openxmlformats.org/drawingml/2006/main" xmlns:r="http://schemas.openxmlformats.org/officeDocument/2006/relationships" xmlns:p="http://schemas.openxmlformats.org/presentationml/2006/main">
+  <p:cSld>
+    <p:spTree>
+      <p:nvGrpSpPr>
+        <p:cNvPr id="1" name=""/>
+        <p:cNvGrpSpPr/>
+        <p:nvPr/>
+      </p:nvGrpSpPr>
+      <p:grpSpPr>
+        <a:xfrm>
+          <a:off x="0" y="0"/>
+          <a:ext cx="0" cy="0"/>
+          <a:chOff x="0" y="0"/>
+          <a:chExt cx="0" cy="0"/>
+        </a:xfrm>
+      </p:grpSpPr>
+      <p:sp>
+        <p:nvSpPr>
+          <p:cNvPr id="2" name="Titel 1">
+            <a:extLst>
+              <a:ext uri="{FF2B5EF4-FFF2-40B4-BE49-F238E27FC236}">
+                <a16:creationId xmlns:a16="http://schemas.microsoft.com/office/drawing/2014/main" id="{20EF1E6E-F30A-7F8D-50CD-E883ED2259DD}"/>
+              </a:ext>
+            </a:extLst>
+          </p:cNvPr>
+          <p:cNvSpPr>
+            <a:spLocks noGrp="1"/>
+          </p:cNvSpPr>
+          <p:nvPr>
+            <p:ph type="title"/>
+          </p:nvPr>
+        </p:nvSpPr>
+        <p:spPr/>
+        <p:txBody>
+          <a:bodyPr/>
+          <a:lstStyle/>
+          <a:p>
+            <a:r>
+              <a:rPr lang="de-DE" dirty="0"/>
+              <a:t>Next: </a:t>
+            </a:r>
+            <a:r>
+              <a:rPr lang="de-DE" dirty="0" err="1"/>
+              <a:t>Context</a:t>
+            </a:r>
+            <a:r>
+              <a:rPr lang="de-DE" dirty="0"/>
+              <a:t> Engineering</a:t>
+            </a:r>
+          </a:p>
+        </p:txBody>
+      </p:sp>
+      <p:sp>
+        <p:nvSpPr>
+          <p:cNvPr id="3" name="Inhaltsplatzhalter 2">
+            <a:extLst>
+              <a:ext uri="{FF2B5EF4-FFF2-40B4-BE49-F238E27FC236}">
+                <a16:creationId xmlns:a16="http://schemas.microsoft.com/office/drawing/2014/main" id="{AA51F7B0-46FA-7E09-1BEB-4B91C37A0215}"/>
+              </a:ext>
+            </a:extLst>
+          </p:cNvPr>
+          <p:cNvSpPr>
+            <a:spLocks noGrp="1"/>
+          </p:cNvSpPr>
+          <p:nvPr>
+            <p:ph idx="1"/>
+          </p:nvPr>
+        </p:nvSpPr>
+        <p:spPr/>
+        <p:txBody>
+          <a:bodyPr/>
+          <a:lstStyle/>
+          <a:p>
+            <a:pPr marL="0" indent="0">
+              <a:buNone/>
+            </a:pPr>
+            <a:endParaRPr lang="de-DE" dirty="0"/>
+          </a:p>
+          <a:p>
+            <a:pPr marL="0" indent="0">
+              <a:buNone/>
+            </a:pPr>
+            <a:r>
+              <a:rPr lang="de-DE" dirty="0" err="1"/>
+              <a:t>To</a:t>
+            </a:r>
+            <a:r>
+              <a:rPr lang="de-DE" dirty="0"/>
+              <a:t> </a:t>
+            </a:r>
+            <a:r>
+              <a:rPr lang="de-DE" dirty="0" err="1"/>
+              <a:t>get</a:t>
+            </a:r>
+            <a:r>
+              <a:rPr lang="de-DE" dirty="0"/>
+              <a:t> </a:t>
+            </a:r>
+            <a:r>
+              <a:rPr lang="de-DE" dirty="0" err="1"/>
+              <a:t>the</a:t>
+            </a:r>
+            <a:r>
+              <a:rPr lang="de-DE" dirty="0"/>
+              <a:t> </a:t>
+            </a:r>
+            <a:r>
+              <a:rPr lang="de-DE" dirty="0" err="1"/>
+              <a:t>most</a:t>
+            </a:r>
+            <a:r>
+              <a:rPr lang="de-DE" dirty="0"/>
+              <a:t> out </a:t>
+            </a:r>
+            <a:r>
+              <a:rPr lang="de-DE" dirty="0" err="1"/>
+              <a:t>of</a:t>
+            </a:r>
+            <a:r>
+              <a:rPr lang="de-DE" dirty="0"/>
+              <a:t> LLMs, </a:t>
+            </a:r>
+            <a:r>
+              <a:rPr lang="de-DE" dirty="0" err="1"/>
+              <a:t>you</a:t>
+            </a:r>
+            <a:r>
+              <a:rPr lang="de-DE" dirty="0"/>
+              <a:t> </a:t>
+            </a:r>
+            <a:r>
+              <a:rPr lang="de-DE" dirty="0" err="1"/>
+              <a:t>need</a:t>
+            </a:r>
+            <a:r>
+              <a:rPr lang="de-DE" dirty="0"/>
+              <a:t> </a:t>
+            </a:r>
+            <a:r>
+              <a:rPr lang="de-DE" dirty="0" err="1"/>
+              <a:t>to</a:t>
+            </a:r>
+            <a:r>
+              <a:rPr lang="de-DE" dirty="0"/>
+              <a:t> prompt in </a:t>
+            </a:r>
+            <a:r>
+              <a:rPr lang="de-DE" dirty="0" err="1"/>
+              <a:t>the</a:t>
+            </a:r>
+            <a:r>
+              <a:rPr lang="de-DE" dirty="0"/>
+              <a:t> </a:t>
+            </a:r>
+            <a:r>
+              <a:rPr lang="de-DE" dirty="0" err="1"/>
+              <a:t>right</a:t>
+            </a:r>
+            <a:r>
+              <a:rPr lang="de-DE" dirty="0"/>
+              <a:t> </a:t>
+            </a:r>
+            <a:r>
+              <a:rPr lang="de-DE" dirty="0" err="1"/>
+              <a:t>way</a:t>
+            </a:r>
+            <a:r>
+              <a:rPr lang="de-DE" dirty="0"/>
+              <a:t>.</a:t>
+            </a:r>
+          </a:p>
+          <a:p>
+            <a:pPr marL="0" indent="0">
+              <a:buNone/>
+            </a:pPr>
+            <a:r>
+              <a:rPr lang="de-DE" dirty="0">
+                <a:sym typeface="Wingdings" pitchFamily="2" charset="2"/>
+              </a:rPr>
+              <a:t> p</a:t>
+            </a:r>
+            <a:r>
+              <a:rPr lang="de-DE" dirty="0"/>
+              <a:t>rompt </a:t>
+            </a:r>
+            <a:r>
+              <a:rPr lang="de-DE" dirty="0" err="1"/>
+              <a:t>engineering</a:t>
+            </a:r>
+            <a:endParaRPr lang="de-DE" dirty="0"/>
+          </a:p>
+          <a:p>
+            <a:pPr marL="0" indent="0">
+              <a:buNone/>
+            </a:pPr>
+            <a:endParaRPr lang="de-DE" dirty="0"/>
+          </a:p>
+          <a:p>
+            <a:pPr marL="0" indent="0">
+              <a:buNone/>
+            </a:pPr>
+            <a:r>
+              <a:rPr lang="de-DE" dirty="0" err="1"/>
+              <a:t>Furthermore</a:t>
+            </a:r>
+            <a:r>
+              <a:rPr lang="de-DE" dirty="0"/>
+              <a:t>, </a:t>
+            </a:r>
+            <a:r>
+              <a:rPr lang="de-DE" dirty="0" err="1"/>
+              <a:t>the</a:t>
+            </a:r>
+            <a:r>
+              <a:rPr lang="de-DE" dirty="0"/>
+              <a:t> </a:t>
+            </a:r>
+            <a:r>
+              <a:rPr lang="de-DE" dirty="0" err="1"/>
+              <a:t>capabilities</a:t>
+            </a:r>
+            <a:r>
+              <a:rPr lang="de-DE" dirty="0"/>
+              <a:t> </a:t>
+            </a:r>
+            <a:r>
+              <a:rPr lang="de-DE" dirty="0" err="1"/>
+              <a:t>of</a:t>
+            </a:r>
+            <a:r>
+              <a:rPr lang="de-DE" dirty="0"/>
+              <a:t> LLMs </a:t>
+            </a:r>
+            <a:r>
+              <a:rPr lang="de-DE" dirty="0" err="1"/>
+              <a:t>can</a:t>
+            </a:r>
+            <a:r>
+              <a:rPr lang="de-DE" dirty="0"/>
+              <a:t> </a:t>
+            </a:r>
+            <a:r>
+              <a:rPr lang="de-DE" dirty="0" err="1"/>
+              <a:t>be</a:t>
+            </a:r>
+            <a:r>
+              <a:rPr lang="de-DE" dirty="0"/>
+              <a:t> </a:t>
+            </a:r>
+            <a:r>
+              <a:rPr lang="de-DE" dirty="0" err="1"/>
+              <a:t>enhanced</a:t>
+            </a:r>
+            <a:r>
+              <a:rPr lang="de-DE" dirty="0"/>
+              <a:t> </a:t>
+            </a:r>
+            <a:r>
+              <a:rPr lang="de-DE" dirty="0" err="1"/>
+              <a:t>by</a:t>
+            </a:r>
+            <a:r>
+              <a:rPr lang="de-DE" dirty="0"/>
+              <a:t> </a:t>
+            </a:r>
+            <a:r>
+              <a:rPr lang="de-DE" dirty="0" err="1"/>
+              <a:t>including</a:t>
+            </a:r>
+            <a:r>
+              <a:rPr lang="de-DE" dirty="0"/>
+              <a:t> additional </a:t>
+            </a:r>
+            <a:r>
+              <a:rPr lang="de-DE" dirty="0" err="1"/>
+              <a:t>information</a:t>
+            </a:r>
+            <a:r>
+              <a:rPr lang="de-DE" dirty="0"/>
+              <a:t> in </a:t>
+            </a:r>
+            <a:r>
+              <a:rPr lang="de-DE" dirty="0" err="1"/>
+              <a:t>the</a:t>
+            </a:r>
+            <a:r>
+              <a:rPr lang="de-DE" dirty="0"/>
+              <a:t> prompt.</a:t>
+            </a:r>
+          </a:p>
+          <a:p>
+            <a:pPr marL="0" indent="0">
+              <a:buNone/>
+            </a:pPr>
+            <a:r>
+              <a:rPr lang="de-DE" dirty="0">
+                <a:sym typeface="Wingdings" pitchFamily="2" charset="2"/>
+              </a:rPr>
+              <a:t> </a:t>
+            </a:r>
+            <a:r>
+              <a:rPr lang="de-DE" dirty="0" err="1"/>
+              <a:t>context</a:t>
+            </a:r>
+            <a:r>
+              <a:rPr lang="de-DE" dirty="0"/>
+              <a:t> </a:t>
+            </a:r>
+            <a:r>
+              <a:rPr lang="de-DE" dirty="0" err="1"/>
+              <a:t>engineering</a:t>
+            </a:r>
+            <a:endParaRPr lang="de-DE" dirty="0"/>
+          </a:p>
+        </p:txBody>
+      </p:sp>
+      <p:sp>
+        <p:nvSpPr>
+          <p:cNvPr id="4" name="Foliennummernplatzhalter 3">
+            <a:extLst>
+              <a:ext uri="{FF2B5EF4-FFF2-40B4-BE49-F238E27FC236}">
+                <a16:creationId xmlns:a16="http://schemas.microsoft.com/office/drawing/2014/main" id="{DCED79EF-B4D0-08EC-3556-26AD11F2166E}"/>
+              </a:ext>
+            </a:extLst>
+          </p:cNvPr>
+          <p:cNvSpPr>
+            <a:spLocks noGrp="1"/>
+          </p:cNvSpPr>
+          <p:nvPr>
+            <p:ph type="sldNum" sz="quarter" idx="12"/>
+          </p:nvPr>
+        </p:nvSpPr>
+        <p:spPr/>
+        <p:txBody>
+          <a:bodyPr/>
+          <a:lstStyle/>
+          <a:p>
+            <a:fld id="{3D4C94FE-FF23-4504-88E9-14D481113291}" type="slidenum">
+              <a:rPr lang="en-GB" smtClean="0"/>
+              <a:t>17</a:t>
+            </a:fld>
+            <a:endParaRPr lang="en-GB"/>
+          </a:p>
+        </p:txBody>
+      </p:sp>
+    </p:spTree>
+    <p:extLst>
+      <p:ext uri="{BB962C8B-B14F-4D97-AF65-F5344CB8AC3E}">
+        <p14:creationId xmlns:p14="http://schemas.microsoft.com/office/powerpoint/2010/main" val="2350334961"/>
       </p:ext>
     </p:extLst>
   </p:cSld>

</xml_diff>